<commit_message>
Publish approved orchestrator and refresh handoff status
</commit_message>
<xml_diff>
--- a/presentations/Project-overview.pptx
+++ b/presentations/Project-overview.pptx
@@ -5216,7 +5216,7 @@
               </a:defRPr>
             </a:pPr>
             <a:r>
-              <a:t>Use Research Orchestrator at localhost:5678; the final tested fixes await live publication.</a:t>
+              <a:t>Use Research Orchestrator at localhost:5678; the tested fixes are now published.</a:t>
             </a:r>
           </a:p>
         </p:txBody>
@@ -10500,7 +10500,7 @@
               </a:defRPr>
             </a:pPr>
             <a:r>
-              <a:t>Final run 196: all four agents completed; 1/5 peers qualified. Live publication awaits approval.</a:t>
+              <a:t>Final run 196: all four agents completed; 1/5 peers qualified. Tested changes are published.</a:t>
             </a:r>
           </a:p>
         </p:txBody>
@@ -10721,7 +10721,7 @@
               </a:defRPr>
             </a:pPr>
             <a:r>
-              <a:t>Tested workflow proposal, source code and deliverables; live publication is pending approval.</a:t>
+              <a:t>Published workflow, source code and deliverables from the tested implementation.</a:t>
             </a:r>
           </a:p>
         </p:txBody>

</xml_diff>